<commit_message>
refactor: retire synthetic emotion benchmark
</commit_message>
<xml_diff>
--- a/deliverables/advisor_full_summary_20260728/emotion_chatbot_ablation_report.pptx
+++ b/deliverables/advisor_full_summary_20260728/emotion_chatbot_ablation_report.pptx
@@ -2,24 +2,24 @@
 <file path=ppt/presentation.xml><?xml version="1.0" encoding="utf-8"?>
 <p:presentation xmlns:p="http://schemas.openxmlformats.org/presentationml/2006/main">
   <p:sldMasterIdLst>
-    <p:sldMasterId xmlns:r="http://schemas.openxmlformats.org/officeDocument/2006/relationships" id="2147483648" r:id="R470f5d2290304d11"/>
+    <p:sldMasterId xmlns:r="http://schemas.openxmlformats.org/officeDocument/2006/relationships" id="2147483648" r:id="Rfa92c53b202b445b"/>
   </p:sldMasterIdLst>
   <p:notesMasterIdLst>
-    <p:notesMasterId xmlns:r="http://schemas.openxmlformats.org/officeDocument/2006/relationships" r:id="R95c2df64b934495b"/>
+    <p:notesMasterId xmlns:r="http://schemas.openxmlformats.org/officeDocument/2006/relationships" r:id="R0cc7eca70f3b4611"/>
   </p:notesMasterIdLst>
   <p:sldIdLst>
-    <p:sldId xmlns:r="http://schemas.openxmlformats.org/officeDocument/2006/relationships" id="256" r:id="Rc27fb08eadd14f0e"/>
-    <p:sldId xmlns:r="http://schemas.openxmlformats.org/officeDocument/2006/relationships" id="257" r:id="R49be44549dfe44bd"/>
-    <p:sldId xmlns:r="http://schemas.openxmlformats.org/officeDocument/2006/relationships" id="258" r:id="R162ed4321584436c"/>
-    <p:sldId xmlns:r="http://schemas.openxmlformats.org/officeDocument/2006/relationships" id="259" r:id="R7ebff0bff7734294"/>
-    <p:sldId xmlns:r="http://schemas.openxmlformats.org/officeDocument/2006/relationships" id="260" r:id="R67261e17906649e8"/>
-    <p:sldId xmlns:r="http://schemas.openxmlformats.org/officeDocument/2006/relationships" id="261" r:id="Rba848224bc954c7e"/>
-    <p:sldId xmlns:r="http://schemas.openxmlformats.org/officeDocument/2006/relationships" id="262" r:id="Rd969d7a43c19426c"/>
-    <p:sldId xmlns:r="http://schemas.openxmlformats.org/officeDocument/2006/relationships" id="263" r:id="Reb9572bda8d24765"/>
-    <p:sldId xmlns:r="http://schemas.openxmlformats.org/officeDocument/2006/relationships" id="264" r:id="R013f1a06c7114f10"/>
-    <p:sldId xmlns:r="http://schemas.openxmlformats.org/officeDocument/2006/relationships" id="265" r:id="Rb136304b365c4b76"/>
-    <p:sldId xmlns:r="http://schemas.openxmlformats.org/officeDocument/2006/relationships" id="266" r:id="R0c110d4494c3400c"/>
-    <p:sldId xmlns:r="http://schemas.openxmlformats.org/officeDocument/2006/relationships" id="267" r:id="R09247d1a8dce4636"/>
+    <p:sldId xmlns:r="http://schemas.openxmlformats.org/officeDocument/2006/relationships" id="256" r:id="R62554e80a59b4c04"/>
+    <p:sldId xmlns:r="http://schemas.openxmlformats.org/officeDocument/2006/relationships" id="257" r:id="R03ccb7ce06b14007"/>
+    <p:sldId xmlns:r="http://schemas.openxmlformats.org/officeDocument/2006/relationships" id="258" r:id="Rb7341417d74a4861"/>
+    <p:sldId xmlns:r="http://schemas.openxmlformats.org/officeDocument/2006/relationships" id="259" r:id="Re6572d7ffbcd41b4"/>
+    <p:sldId xmlns:r="http://schemas.openxmlformats.org/officeDocument/2006/relationships" id="260" r:id="R0acb9019df4f4cfb"/>
+    <p:sldId xmlns:r="http://schemas.openxmlformats.org/officeDocument/2006/relationships" id="261" r:id="R0021259a13554c2e"/>
+    <p:sldId xmlns:r="http://schemas.openxmlformats.org/officeDocument/2006/relationships" id="262" r:id="R841733abb04c40d7"/>
+    <p:sldId xmlns:r="http://schemas.openxmlformats.org/officeDocument/2006/relationships" id="263" r:id="R67f3118092a34d31"/>
+    <p:sldId xmlns:r="http://schemas.openxmlformats.org/officeDocument/2006/relationships" id="264" r:id="Rc225515dc204481c"/>
+    <p:sldId xmlns:r="http://schemas.openxmlformats.org/officeDocument/2006/relationships" id="265" r:id="Rc3dffe3fb8bf4575"/>
+    <p:sldId xmlns:r="http://schemas.openxmlformats.org/officeDocument/2006/relationships" id="266" r:id="Ra2fc868c897641fc"/>
+    <p:sldId xmlns:r="http://schemas.openxmlformats.org/officeDocument/2006/relationships" id="267" r:id="R3486d1f1ad714840"/>
   </p:sldIdLst>
   <p:sldSz cx="12192000" cy="6858000"/>
   <p:notesSz cx="6858000" cy="9144000"/>
@@ -453,7 +453,7 @@
           <a:lstStyle xmlns:a="http://schemas.openxmlformats.org/drawingml/2006/main"/>
           <a:p xmlns:a="http://schemas.openxmlformats.org/drawingml/2006/main">
             <a:r>
-              <a:t>先交代三条主线：聊天机器人、消融实验、真实数据评测修正。</a:t>
+              <a:t>先交代三条主线：聊天机器人、消融框架、公开数据评测。</a:t>
             </a:r>
           </a:p>
           <a:p xmlns:a="http://schemas.openxmlformats.org/drawingml/2006/main">
@@ -473,7 +473,7 @@
           </a:p>
           <a:p xmlns:a="http://schemas.openxmlformats.org/drawingml/2006/main">
             <a:r>
-              <a:t>- data/benchmarks/empathetic_dialogues_v1/reports/remediation_report.md</a:t>
+              <a:t>- data/benchmarks/empathetic_dialogues_v1/README.md</a:t>
             </a:r>
           </a:p>
         </p:txBody>
@@ -543,7 +543,7 @@
           <a:lstStyle xmlns:a="http://schemas.openxmlformats.org/drawingml/2006/main"/>
           <a:p xmlns:a="http://schemas.openxmlformats.org/drawingml/2006/main">
             <a:r>
-              <a:t>报告方向性结果和置信区间边界；明确不能把修复前后直接解释为 30 个百分点提升。</a:t>
+              <a:t>报告方向性结果；明确 32 条 pilot 不能支持统计显著性结论。</a:t>
             </a:r>
           </a:p>
           <a:p xmlns:a="http://schemas.openxmlformats.org/drawingml/2006/main">
@@ -563,7 +563,7 @@
           </a:p>
           <a:p xmlns:a="http://schemas.openxmlformats.org/drawingml/2006/main">
             <a:r>
-              <a:t>- data/benchmarks/empathetic_dialogues_v1/reports/remediation_report.md:50-64</a:t>
+              <a:t>- data/benchmarks/empathetic_dialogues_v1/reports/remediation_report.md</a:t>
             </a:r>
           </a:p>
         </p:txBody>
@@ -633,7 +633,7 @@
           <a:lstStyle xmlns:a="http://schemas.openxmlformats.org/drawingml/2006/main"/>
           <a:p xmlns:a="http://schemas.openxmlformats.org/drawingml/2006/main">
             <a:r>
-              <a:t>按成本和证据强度说明近期、中期、后续三层计划。</a:t>
+              <a:t>按证据强度说明 64 条配对检验、完整 test 与逐句标注多轮数据三个层次。</a:t>
             </a:r>
           </a:p>
           <a:p xmlns:a="http://schemas.openxmlformats.org/drawingml/2006/main">
@@ -648,7 +648,7 @@
           </a:p>
           <a:p xmlns:a="http://schemas.openxmlformats.org/drawingml/2006/main">
             <a:r>
-              <a:t>- data/benchmarks/empathetic_dialogues_v1/reports/remediation_report.md:97-102</a:t>
+              <a:t>- data/benchmarks/empathetic_dialogues_v1/reports/remediation_report.md</a:t>
             </a:r>
           </a:p>
         </p:txBody>
@@ -718,7 +718,7 @@
           <a:lstStyle xmlns:a="http://schemas.openxmlformats.org/drawingml/2006/main"/>
           <a:p xmlns:a="http://schemas.openxmlformats.org/drawingml/2006/main">
             <a:r>
-              <a:t>用三项已完成工作和三阶段后续计划收束，不夸大当前小样本结果。</a:t>
+              <a:t>用公开数据、可复现消融和后续统计验证收束，不夸大当前小样本结果。</a:t>
             </a:r>
           </a:p>
           <a:p xmlns:a="http://schemas.openxmlformats.org/drawingml/2006/main">
@@ -733,7 +733,7 @@
           </a:p>
           <a:p xmlns:a="http://schemas.openxmlformats.org/drawingml/2006/main">
             <a:r>
-              <a:t>- README.md:476-487</a:t>
+              <a:t>- README.md</a:t>
             </a:r>
           </a:p>
           <a:p xmlns:a="http://schemas.openxmlformats.org/drawingml/2006/main">
@@ -898,7 +898,7 @@
           <a:lstStyle xmlns:a="http://schemas.openxmlformats.org/drawingml/2006/main"/>
           <a:p xmlns:a="http://schemas.openxmlformats.org/drawingml/2006/main">
             <a:r>
-              <a:t>说明消融的核心是控制变量，不是简单比较多个 Prompt 名称。</a:t>
+              <a:t>说明框架拆分了三个组件；当前公开基准只能有效验证示例策略，历史和上下文需要逐句标注的多轮数据。</a:t>
             </a:r>
           </a:p>
           <a:p xmlns:a="http://schemas.openxmlformats.org/drawingml/2006/main">
@@ -913,12 +913,12 @@
           </a:p>
           <a:p xmlns:a="http://schemas.openxmlformats.org/drawingml/2006/main">
             <a:r>
-              <a:t>- README.md:236-242</a:t>
-            </a:r>
-          </a:p>
-          <a:p xmlns:a="http://schemas.openxmlformats.org/drawingml/2006/main">
-            <a:r>
-              <a:t>- README.md:323-357</a:t>
+              <a:t>- README.md</a:t>
+            </a:r>
+          </a:p>
+          <a:p xmlns:a="http://schemas.openxmlformats.org/drawingml/2006/main">
+            <a:r>
+              <a:t>- data/benchmarks/empathetic_dialogues_v1/README.md</a:t>
             </a:r>
           </a:p>
         </p:txBody>
@@ -988,7 +988,7 @@
           <a:lstStyle xmlns:a="http://schemas.openxmlformats.org/drawingml/2006/main"/>
           <a:p xmlns:a="http://schemas.openxmlformats.org/drawingml/2006/main">
             <a:r>
-              <a:t>肯定合成数据的工程价值，同时明确它不能作为真实效果的主要证据。</a:t>
+              <a:t>强调当前正式实验只使用公开基准，自建生成数据、脚本和旧结果已从仓库退役。</a:t>
             </a:r>
           </a:p>
           <a:p xmlns:a="http://schemas.openxmlformats.org/drawingml/2006/main">
@@ -1003,12 +1003,12 @@
           </a:p>
           <a:p xmlns:a="http://schemas.openxmlformats.org/drawingml/2006/main">
             <a:r>
-              <a:t>- data/benchmarks/emotion_ablation_v2/README.md:3-33</a:t>
-            </a:r>
-          </a:p>
-          <a:p xmlns:a="http://schemas.openxmlformats.org/drawingml/2006/main">
-            <a:r>
-              <a:t>- data/benchmarks/emotion_ablation_v2/reports/quality_report.md:1-23</a:t>
+              <a:t>- data/benchmarks/empathetic_dialogues_v1/metadata.json</a:t>
+            </a:r>
+          </a:p>
+          <a:p xmlns:a="http://schemas.openxmlformats.org/drawingml/2006/main">
+            <a:r>
+              <a:t>- data/benchmarks/empathetic_dialogues_v1/reports/dataset_card.md</a:t>
             </a:r>
           </a:p>
         </p:txBody>
@@ -1078,7 +1078,7 @@
           <a:lstStyle xmlns:a="http://schemas.openxmlformats.org/drawingml/2006/main"/>
           <a:p xmlns:a="http://schemas.openxmlformats.org/drawingml/2006/main">
             <a:r>
-              <a:t>逐行解释五组配置，并提醒 zero-shot 不是单变量消融。</a:t>
+              <a:t>逐行解释五组配置，并提醒 zero-shot 不是单变量消融；无实际 Prompt 差异的配置会被跳过。</a:t>
             </a:r>
           </a:p>
           <a:p xmlns:a="http://schemas.openxmlformats.org/drawingml/2006/main">
@@ -1093,7 +1093,7 @@
           </a:p>
           <a:p xmlns:a="http://schemas.openxmlformats.org/drawingml/2006/main">
             <a:r>
-              <a:t>- README.md:323-357</a:t>
+              <a:t>- README.md</a:t>
             </a:r>
           </a:p>
         </p:txBody>
@@ -1163,7 +1163,7 @@
           <a:lstStyle xmlns:a="http://schemas.openxmlformats.org/drawingml/2006/main"/>
           <a:p xmlns:a="http://schemas.openxmlformats.org/drawingml/2006/main">
             <a:r>
-              <a:t>说明切换数据集是为了提升外部可查性与现实参考性，不是否定合成数据的全部价值。</a:t>
+              <a:t>说明数据选型标准和 EmpatheticDialogues 的标签语义边界。</a:t>
             </a:r>
           </a:p>
           <a:p xmlns:a="http://schemas.openxmlformats.org/drawingml/2006/main">
@@ -1178,7 +1178,12 @@
           </a:p>
           <a:p xmlns:a="http://schemas.openxmlformats.org/drawingml/2006/main">
             <a:r>
-              <a:t>- data/benchmarks/empathetic_dialogues_v1/README.md:3-15</a:t>
+              <a:t>- data/benchmarks/empathetic_dialogues_v1/README.md</a:t>
+            </a:r>
+          </a:p>
+          <a:p xmlns:a="http://schemas.openxmlformats.org/drawingml/2006/main">
+            <a:r>
+              <a:t>- data/benchmarks/empathetic_dialogues_v1/reports/dataset_card.md</a:t>
             </a:r>
           </a:p>
         </p:txBody>
@@ -1248,7 +1253,7 @@
           <a:lstStyle xmlns:a="http://schemas.openxmlformats.org/drawingml/2006/main"/>
           <a:p xmlns:a="http://schemas.openxmlformats.org/drawingml/2006/main">
             <a:r>
-              <a:t>先解释最严重的标签/输入错位，再讲样本覆盖、检索和 no-op 问题。</a:t>
+              <a:t>先解释标签与输入错位，再讲样本覆盖、检索和 no-op 问题。</a:t>
             </a:r>
           </a:p>
           <a:p xmlns:a="http://schemas.openxmlformats.org/drawingml/2006/main">
@@ -1263,12 +1268,12 @@
           </a:p>
           <a:p xmlns:a="http://schemas.openxmlformats.org/drawingml/2006/main">
             <a:r>
-              <a:t>- data/benchmarks/empathetic_dialogues_v1/reports/remediation_report.md:3-29</a:t>
-            </a:r>
-          </a:p>
-          <a:p xmlns:a="http://schemas.openxmlformats.org/drawingml/2006/main">
-            <a:r>
-              <a:t>- data/benchmarks/empathetic_dialogues_v1/reports/codex_pilot10/report-zh.md:11-24</a:t>
+              <a:t>- data/benchmarks/empathetic_dialogues_v1/reports/remediation_report.md</a:t>
+            </a:r>
+          </a:p>
+          <a:p xmlns:a="http://schemas.openxmlformats.org/drawingml/2006/main">
+            <a:r>
+              <a:t>- data/benchmarks/empathetic_dialogues_v1/reports/codex_pilot10/report-zh.md</a:t>
             </a:r>
           </a:p>
         </p:txBody>
@@ -1511,7 +1516,7 @@
   </p:cSld>
   <p:clrMap bg1="lt1" tx1="dk1" bg2="lt2" tx2="dk2" accent1="accent1" accent2="accent2" accent3="accent3" accent4="accent4" accent5="accent5" accent6="accent6" hlink="hlink" folHlink="folHlink"/>
   <p:sldLayoutIdLst>
-    <p:sldLayoutId xmlns:r="http://schemas.openxmlformats.org/officeDocument/2006/relationships" id="2147483649" r:id="Rd798ab26a7914522"/>
+    <p:sldLayoutId xmlns:r="http://schemas.openxmlformats.org/officeDocument/2006/relationships" id="2147483649" r:id="Rdc3e04d51a3340aa"/>
   </p:sldLayoutIdLst>
   <p:txStyles>
     <p:titleStyle>
@@ -2231,6 +2236,7 @@
           <a:lstStyle xmlns:a="http://schemas.openxmlformats.org/drawingml/2006/main"/>
           <a:p xmlns:a="http://schemas.openxmlformats.org/drawingml/2006/main">
             <a:pPr algn="l">
+              <a:buNone/>
               <a:defRPr sz="6000">
                 <a:solidFill>
                   <a:srgbClr val="000000"/>
@@ -2277,6 +2283,7 @@
           <a:lstStyle xmlns:a="http://schemas.openxmlformats.org/drawingml/2006/main"/>
           <a:p xmlns:a="http://schemas.openxmlformats.org/drawingml/2006/main">
             <a:pPr algn="l">
+              <a:buNone/>
               <a:defRPr sz="2400">
                 <a:solidFill>
                   <a:srgbClr val="000000"/>
@@ -2287,7 +2294,7 @@
               </a:defRPr>
             </a:pPr>
             <a:r>
-              <a:t>从合成数据到开源真实数据的评测修正
+              <a:t>基于 EmpatheticDialogues 的公开数据评测
 2026.07</a:t>
             </a:r>
           </a:p>
@@ -2323,6 +2330,7 @@
           <a:lstStyle xmlns:a="http://schemas.openxmlformats.org/drawingml/2006/main"/>
           <a:p xmlns:a="http://schemas.openxmlformats.org/drawingml/2006/main">
             <a:pPr algn="l">
+              <a:buNone/>
               <a:defRPr sz="2400">
                 <a:solidFill>
                   <a:srgbClr val="000000"/>
@@ -2390,6 +2398,7 @@
           <a:lstStyle xmlns:a="http://schemas.openxmlformats.org/drawingml/2006/main"/>
           <a:p xmlns:a="http://schemas.openxmlformats.org/drawingml/2006/main">
             <a:pPr algn="r">
+              <a:buNone/>
               <a:defRPr sz="1000">
                 <a:solidFill>
                   <a:srgbClr val="000000"/>
@@ -2435,17 +2444,26 @@
           <a:lstStyle xmlns:a="http://schemas.openxmlformats.org/drawingml/2006/main"/>
           <a:p xmlns:a="http://schemas.openxmlformats.org/drawingml/2006/main">
             <a:pPr algn="l">
-              <a:defRPr sz="2900">
-                <a:solidFill>
-                  <a:srgbClr val="000000"/>
-                </a:solidFill>
-                <a:latin typeface="Helvetica Neue"/>
-                <a:ea typeface="Helvetica Neue"/>
-                <a:cs typeface="Helvetica Neue"/>
-              </a:defRPr>
-            </a:pPr>
-            <a:r>
-              <a:t>修复后准确率约为 56%–59%</a:t>
+              <a:buNone/>
+              <a:defRPr sz="3000">
+                <a:solidFill>
+                  <a:srgbClr val="000000"/>
+                </a:solidFill>
+                <a:latin typeface="Helvetica Neue"/>
+                <a:ea typeface="Helvetica Neue"/>
+                <a:cs typeface="Helvetica Neue"/>
+              </a:defRPr>
+            </a:pPr>
+            <a:r>
+              <a:rPr sz="3000">
+                <a:solidFill>
+                  <a:srgbClr val="000000"/>
+                </a:solidFill>
+                <a:latin typeface="Helvetica Neue"/>
+                <a:ea typeface="Helvetica Neue"/>
+                <a:cs typeface="Helvetica Neue"/>
+              </a:rPr>
+              <a:t>公开数据 pilot：56%–59%</a:t>
             </a:r>
           </a:p>
         </p:txBody>
@@ -2509,6 +2527,7 @@
           <a:lstStyle xmlns:a="http://schemas.openxmlformats.org/drawingml/2006/main"/>
           <a:p xmlns:a="http://schemas.openxmlformats.org/drawingml/2006/main">
             <a:pPr algn="l">
+              <a:buNone/>
               <a:defRPr sz="2400">
                 <a:solidFill>
                   <a:srgbClr val="000000"/>
@@ -2524,6 +2543,7 @@
           </a:p>
           <a:p xmlns:a="http://schemas.openxmlformats.org/drawingml/2006/main">
             <a:pPr algn="l">
+              <a:buNone/>
               <a:defRPr sz="2400">
                 <a:solidFill>
                   <a:srgbClr val="000000"/>
@@ -2598,6 +2618,7 @@
           <a:lstStyle xmlns:a="http://schemas.openxmlformats.org/drawingml/2006/main"/>
           <a:p xmlns:a="http://schemas.openxmlformats.org/drawingml/2006/main">
             <a:pPr algn="l">
+              <a:buNone/>
               <a:defRPr sz="2400">
                 <a:solidFill>
                   <a:srgbClr val="000000"/>
@@ -2613,6 +2634,7 @@
           </a:p>
           <a:p xmlns:a="http://schemas.openxmlformats.org/drawingml/2006/main">
             <a:pPr algn="l">
+              <a:buNone/>
               <a:defRPr sz="2400">
                 <a:solidFill>
                   <a:srgbClr val="000000"/>
@@ -2687,6 +2709,7 @@
           <a:lstStyle xmlns:a="http://schemas.openxmlformats.org/drawingml/2006/main"/>
           <a:p xmlns:a="http://schemas.openxmlformats.org/drawingml/2006/main">
             <a:pPr algn="l">
+              <a:buNone/>
               <a:defRPr sz="2400">
                 <a:solidFill>
                   <a:srgbClr val="000000"/>
@@ -2702,6 +2725,7 @@
           </a:p>
           <a:p xmlns:a="http://schemas.openxmlformats.org/drawingml/2006/main">
             <a:pPr algn="l">
+              <a:buNone/>
               <a:defRPr sz="2400">
                 <a:solidFill>
                   <a:srgbClr val="000000"/>
@@ -2750,7 +2774,7 @@
       </p:sp>
       <p:graphicFrame>
         <p:nvGraphicFramePr>
-          <p:cNvPr id="21" name="Chart"/>
+          <p:cNvPr id="23" name="Chart"/>
           <p:cNvGraphicFramePr/>
           <p:nvPr/>
         </p:nvGraphicFramePr>
@@ -2760,7 +2784,7 @@
         </p:xfrm>
         <a:graphic xmlns:a="http://schemas.openxmlformats.org/drawingml/2006/main">
           <a:graphicData uri="http://schemas.openxmlformats.org/drawingml/2006/chart">
-            <c:chart xmlns:r="http://schemas.openxmlformats.org/officeDocument/2006/relationships" xmlns:c="http://schemas.openxmlformats.org/drawingml/2006/chart" r:id="R7ad70907d2174216"/>
+            <c:chart xmlns:r="http://schemas.openxmlformats.org/officeDocument/2006/relationships" xmlns:c="http://schemas.openxmlformats.org/drawingml/2006/chart" r:id="Reb87700f00ae49a7"/>
           </a:graphicData>
         </a:graphic>
       </p:graphicFrame>
@@ -2845,6 +2869,7 @@
           <a:lstStyle xmlns:a="http://schemas.openxmlformats.org/drawingml/2006/main"/>
           <a:p xmlns:a="http://schemas.openxmlformats.org/drawingml/2006/main">
             <a:pPr algn="r">
+              <a:buNone/>
               <a:defRPr sz="1000">
                 <a:solidFill>
                   <a:srgbClr val="000000"/>
@@ -2890,6 +2915,7 @@
           <a:lstStyle xmlns:a="http://schemas.openxmlformats.org/drawingml/2006/main"/>
           <a:p xmlns:a="http://schemas.openxmlformats.org/drawingml/2006/main">
             <a:pPr algn="l">
+              <a:buNone/>
               <a:defRPr sz="2900">
                 <a:solidFill>
                   <a:srgbClr val="000000"/>
@@ -2907,7 +2933,7 @@
       </p:sp>
       <p:cxnSp>
         <p:nvCxnSpPr>
-          <p:cNvPr id="15" name="Google-Shape-2259-p159-4"/>
+          <p:cNvPr id="30" name="Google-Shape-2259-p159-4"/>
           <p:cNvCxnSpPr/>
           <p:nvPr/>
         </p:nvCxnSpPr>
@@ -3038,6 +3064,7 @@
           <a:lstStyle xmlns:a="http://schemas.openxmlformats.org/drawingml/2006/main"/>
           <a:p xmlns:a="http://schemas.openxmlformats.org/drawingml/2006/main">
             <a:pPr algn="l">
+              <a:buNone/>
               <a:defRPr sz="1600">
                 <a:solidFill>
                   <a:srgbClr val="000000"/>
@@ -3083,6 +3110,7 @@
           <a:lstStyle xmlns:a="http://schemas.openxmlformats.org/drawingml/2006/main"/>
           <a:p xmlns:a="http://schemas.openxmlformats.org/drawingml/2006/main">
             <a:pPr algn="l">
+              <a:buNone/>
               <a:defRPr sz="1600">
                 <a:solidFill>
                   <a:srgbClr val="000000"/>
@@ -3128,6 +3156,7 @@
           <a:lstStyle xmlns:a="http://schemas.openxmlformats.org/drawingml/2006/main"/>
           <a:p xmlns:a="http://schemas.openxmlformats.org/drawingml/2006/main">
             <a:pPr algn="l">
+              <a:buNone/>
               <a:defRPr sz="1600">
                 <a:solidFill>
                   <a:srgbClr val="000000"/>
@@ -3173,6 +3202,7 @@
           <a:lstStyle xmlns:a="http://schemas.openxmlformats.org/drawingml/2006/main"/>
           <a:p xmlns:a="http://schemas.openxmlformats.org/drawingml/2006/main">
             <a:pPr algn="l">
+              <a:buNone/>
               <a:defRPr sz="2400">
                 <a:solidFill>
                   <a:srgbClr val="000000"/>
@@ -3188,6 +3218,7 @@
           </a:p>
           <a:p xmlns:a="http://schemas.openxmlformats.org/drawingml/2006/main">
             <a:pPr algn="l">
+              <a:buNone/>
               <a:defRPr sz="2400">
                 <a:solidFill>
                   <a:srgbClr val="000000"/>
@@ -3198,8 +3229,11 @@
               </a:defRPr>
             </a:pPr>
             <a:r>
-              <a:t>混淆矩阵与类别召回
-定位细粒度边界</a:t>
+              <a:t>人工抽查标签对齐</a:t>
+            </a:r>
+            <a:br/>
+            <a:r>
+              <a:t>混淆矩阵与显著性</a:t>
             </a:r>
           </a:p>
         </p:txBody>
@@ -3234,6 +3268,7 @@
           <a:lstStyle xmlns:a="http://schemas.openxmlformats.org/drawingml/2006/main"/>
           <a:p xmlns:a="http://schemas.openxmlformats.org/drawingml/2006/main">
             <a:pPr algn="l">
+              <a:buNone/>
               <a:defRPr sz="2400">
                 <a:solidFill>
                   <a:srgbClr val="000000"/>
@@ -3249,6 +3284,7 @@
           </a:p>
           <a:p xmlns:a="http://schemas.openxmlformats.org/drawingml/2006/main">
             <a:pPr algn="l">
+              <a:buNone/>
               <a:defRPr sz="2400">
                 <a:solidFill>
                   <a:srgbClr val="000000"/>
@@ -3259,8 +3295,11 @@
               </a:defRPr>
             </a:pPr>
             <a:r>
-              <a:t>每类 2 条
-继续报告 95% CI</a:t>
+              <a:t>保存逐条预测</a:t>
+            </a:r>
+            <a:br/>
+            <a:r>
+              <a:t>配对检验与差值 CI</a:t>
             </a:r>
           </a:p>
         </p:txBody>
@@ -3295,6 +3334,7 @@
           <a:lstStyle xmlns:a="http://schemas.openxmlformats.org/drawingml/2006/main"/>
           <a:p xmlns:a="http://schemas.openxmlformats.org/drawingml/2006/main">
             <a:pPr algn="l">
+              <a:buNone/>
               <a:defRPr sz="2400">
                 <a:solidFill>
                   <a:srgbClr val="000000"/>
@@ -3310,6 +3350,7 @@
           </a:p>
           <a:p xmlns:a="http://schemas.openxmlformats.org/drawingml/2006/main">
             <a:pPr algn="l">
+              <a:buNone/>
               <a:defRPr sz="2400">
                 <a:solidFill>
                   <a:srgbClr val="000000"/>
@@ -3378,6 +3419,7 @@
           <a:lstStyle xmlns:a="http://schemas.openxmlformats.org/drawingml/2006/main"/>
           <a:p xmlns:a="http://schemas.openxmlformats.org/drawingml/2006/main">
             <a:pPr algn="l">
+              <a:buNone/>
               <a:defRPr sz="6000">
                 <a:solidFill>
                   <a:srgbClr val="000000"/>
@@ -3388,7 +3430,7 @@
               </a:defRPr>
             </a:pPr>
             <a:r>
-              <a:t>先把评测做对，
+              <a:t>以公开数据为依据，
 再讨论模型好坏</a:t>
             </a:r>
           </a:p>
@@ -3424,6 +3466,7 @@
           <a:lstStyle xmlns:a="http://schemas.openxmlformats.org/drawingml/2006/main"/>
           <a:p xmlns:a="http://schemas.openxmlformats.org/drawingml/2006/main">
             <a:pPr algn="l">
+              <a:buNone/>
               <a:defRPr sz="2400">
                 <a:solidFill>
                   <a:srgbClr val="000000"/>
@@ -3439,6 +3482,7 @@
           </a:p>
           <a:p xmlns:a="http://schemas.openxmlformats.org/drawingml/2006/main">
             <a:pPr algn="l">
+              <a:buNone/>
               <a:defRPr sz="2400">
                 <a:solidFill>
                   <a:srgbClr val="000000"/>
@@ -3454,6 +3498,7 @@
           </a:p>
           <a:p xmlns:a="http://schemas.openxmlformats.org/drawingml/2006/main">
             <a:pPr algn="l">
+              <a:buNone/>
               <a:defRPr sz="2400">
                 <a:solidFill>
                   <a:srgbClr val="000000"/>
@@ -3464,7 +3509,7 @@
               </a:defRPr>
             </a:pPr>
             <a:r>
-              <a:t>真实数据可追溯</a:t>
+              <a:t>公开基准可追溯</a:t>
             </a:r>
           </a:p>
         </p:txBody>
@@ -3499,6 +3544,7 @@
           <a:lstStyle xmlns:a="http://schemas.openxmlformats.org/drawingml/2006/main"/>
           <a:p xmlns:a="http://schemas.openxmlformats.org/drawingml/2006/main">
             <a:pPr algn="l">
+              <a:buNone/>
               <a:defRPr sz="2400">
                 <a:solidFill>
                   <a:srgbClr val="000000"/>
@@ -3564,6 +3610,7 @@
           <a:lstStyle xmlns:a="http://schemas.openxmlformats.org/drawingml/2006/main"/>
           <a:p xmlns:a="http://schemas.openxmlformats.org/drawingml/2006/main">
             <a:pPr algn="r">
+              <a:buNone/>
               <a:defRPr sz="1000">
                 <a:solidFill>
                   <a:srgbClr val="000000"/>
@@ -3609,6 +3656,7 @@
           <a:lstStyle xmlns:a="http://schemas.openxmlformats.org/drawingml/2006/main"/>
           <a:p xmlns:a="http://schemas.openxmlformats.org/drawingml/2006/main">
             <a:pPr algn="l">
+              <a:buNone/>
               <a:defRPr sz="2900">
                 <a:solidFill>
                   <a:srgbClr val="000000"/>
@@ -3626,7 +3674,7 @@
       </p:sp>
       <p:cxnSp>
         <p:nvCxnSpPr>
-          <p:cNvPr id="15" name="Google-Shape-2259-p159-4"/>
+          <p:cNvPr id="30" name="Google-Shape-2259-p159-4"/>
           <p:cNvCxnSpPr/>
           <p:nvPr/>
         </p:nvCxnSpPr>
@@ -3757,6 +3805,7 @@
           <a:lstStyle xmlns:a="http://schemas.openxmlformats.org/drawingml/2006/main"/>
           <a:p xmlns:a="http://schemas.openxmlformats.org/drawingml/2006/main">
             <a:pPr algn="l">
+              <a:buNone/>
               <a:defRPr sz="1600">
                 <a:solidFill>
                   <a:srgbClr val="000000"/>
@@ -3802,6 +3851,7 @@
           <a:lstStyle xmlns:a="http://schemas.openxmlformats.org/drawingml/2006/main"/>
           <a:p xmlns:a="http://schemas.openxmlformats.org/drawingml/2006/main">
             <a:pPr algn="l">
+              <a:buNone/>
               <a:defRPr sz="1600">
                 <a:solidFill>
                   <a:srgbClr val="000000"/>
@@ -3847,6 +3897,7 @@
           <a:lstStyle xmlns:a="http://schemas.openxmlformats.org/drawingml/2006/main"/>
           <a:p xmlns:a="http://schemas.openxmlformats.org/drawingml/2006/main">
             <a:pPr algn="l">
+              <a:buNone/>
               <a:defRPr sz="1600">
                 <a:solidFill>
                   <a:srgbClr val="000000"/>
@@ -3892,6 +3943,7 @@
           <a:lstStyle xmlns:a="http://schemas.openxmlformats.org/drawingml/2006/main"/>
           <a:p xmlns:a="http://schemas.openxmlformats.org/drawingml/2006/main">
             <a:pPr algn="l">
+              <a:buNone/>
               <a:defRPr sz="2400">
                 <a:solidFill>
                   <a:srgbClr val="000000"/>
@@ -3907,6 +3959,7 @@
           </a:p>
           <a:p xmlns:a="http://schemas.openxmlformats.org/drawingml/2006/main">
             <a:pPr algn="l">
+              <a:buNone/>
               <a:defRPr sz="2400">
                 <a:solidFill>
                   <a:srgbClr val="000000"/>
@@ -3953,6 +4006,7 @@
           <a:lstStyle xmlns:a="http://schemas.openxmlformats.org/drawingml/2006/main"/>
           <a:p xmlns:a="http://schemas.openxmlformats.org/drawingml/2006/main">
             <a:pPr algn="l">
+              <a:buNone/>
               <a:defRPr sz="2400">
                 <a:solidFill>
                   <a:srgbClr val="000000"/>
@@ -3968,6 +4022,7 @@
           </a:p>
           <a:p xmlns:a="http://schemas.openxmlformats.org/drawingml/2006/main">
             <a:pPr algn="l">
+              <a:buNone/>
               <a:defRPr sz="2400">
                 <a:solidFill>
                   <a:srgbClr val="000000"/>
@@ -4014,6 +4069,7 @@
           <a:lstStyle xmlns:a="http://schemas.openxmlformats.org/drawingml/2006/main"/>
           <a:p xmlns:a="http://schemas.openxmlformats.org/drawingml/2006/main">
             <a:pPr algn="l">
+              <a:buNone/>
               <a:defRPr sz="2400">
                 <a:solidFill>
                   <a:srgbClr val="000000"/>
@@ -4029,6 +4085,7 @@
           </a:p>
           <a:p xmlns:a="http://schemas.openxmlformats.org/drawingml/2006/main">
             <a:pPr algn="l">
+              <a:buNone/>
               <a:defRPr sz="2400">
                 <a:solidFill>
                   <a:srgbClr val="000000"/>
@@ -4097,6 +4154,7 @@
           <a:lstStyle xmlns:a="http://schemas.openxmlformats.org/drawingml/2006/main"/>
           <a:p xmlns:a="http://schemas.openxmlformats.org/drawingml/2006/main">
             <a:pPr algn="r">
+              <a:buNone/>
               <a:defRPr sz="1000">
                 <a:solidFill>
                   <a:srgbClr val="000000"/>
@@ -4142,6 +4200,7 @@
           <a:lstStyle xmlns:a="http://schemas.openxmlformats.org/drawingml/2006/main"/>
           <a:p xmlns:a="http://schemas.openxmlformats.org/drawingml/2006/main">
             <a:pPr algn="l">
+              <a:buNone/>
               <a:defRPr sz="2900">
                 <a:solidFill>
                   <a:srgbClr val="000000"/>
@@ -4152,7 +4211,7 @@
               </a:defRPr>
             </a:pPr>
             <a:r>
-              <a:t>消融实验验证三个可开关组件</a:t>
+              <a:t>消融框架拆分三个可开关组件</a:t>
             </a:r>
           </a:p>
         </p:txBody>
@@ -4187,6 +4246,7 @@
           <a:lstStyle xmlns:a="http://schemas.openxmlformats.org/drawingml/2006/main"/>
           <a:p xmlns:a="http://schemas.openxmlformats.org/drawingml/2006/main">
             <a:pPr algn="l">
+              <a:buNone/>
               <a:defRPr sz="2400">
                 <a:solidFill>
                   <a:srgbClr val="000000"/>
@@ -4233,6 +4293,7 @@
           <a:lstStyle xmlns:a="http://schemas.openxmlformats.org/drawingml/2006/main"/>
           <a:p xmlns:a="http://schemas.openxmlformats.org/drawingml/2006/main">
             <a:pPr algn="l">
+              <a:buNone/>
               <a:defRPr sz="2400">
                 <a:solidFill>
                   <a:srgbClr val="000000"/>
@@ -4279,6 +4340,7 @@
           <a:lstStyle xmlns:a="http://schemas.openxmlformats.org/drawingml/2006/main"/>
           <a:p xmlns:a="http://schemas.openxmlformats.org/drawingml/2006/main">
             <a:pPr algn="l">
+              <a:buNone/>
               <a:defRPr sz="2400">
                 <a:solidFill>
                   <a:srgbClr val="000000"/>
@@ -4993,6 +5055,7 @@
           <a:lstStyle xmlns:a="http://schemas.openxmlformats.org/drawingml/2006/main"/>
           <a:p xmlns:a="http://schemas.openxmlformats.org/drawingml/2006/main">
             <a:pPr algn="r">
+              <a:buNone/>
               <a:defRPr sz="1000">
                 <a:solidFill>
                   <a:srgbClr val="000000"/>
@@ -5038,6 +5101,7 @@
           <a:lstStyle xmlns:a="http://schemas.openxmlformats.org/drawingml/2006/main"/>
           <a:p xmlns:a="http://schemas.openxmlformats.org/drawingml/2006/main">
             <a:pPr algn="l">
+              <a:buNone/>
               <a:defRPr sz="2900">
                 <a:solidFill>
                   <a:srgbClr val="000000"/>
@@ -5048,7 +5112,7 @@
               </a:defRPr>
             </a:pPr>
             <a:r>
-              <a:t>第一阶段先用合成数据验证实验链路</a:t>
+              <a:t>正式实验只采用公开、可追溯数据</a:t>
             </a:r>
           </a:p>
         </p:txBody>
@@ -5078,11 +5142,12 @@
         </p:spPr>
         <p:txBody>
           <a:bodyPr xmlns:a="http://schemas.openxmlformats.org/drawingml/2006/main" lIns="91440" tIns="45720" rIns="91440" bIns="45720">
-            <a:normAutofit fontScale="99398"/>
+            <a:normAutofit fontScale="99479"/>
           </a:bodyPr>
           <a:lstStyle xmlns:a="http://schemas.openxmlformats.org/drawingml/2006/main"/>
           <a:p xmlns:a="http://schemas.openxmlformats.org/drawingml/2006/main">
             <a:pPr algn="l">
+              <a:buNone/>
               <a:defRPr sz="2400">
                 <a:solidFill>
                   <a:srgbClr val="000000"/>
@@ -5093,8 +5158,8 @@
               </a:defRPr>
             </a:pPr>
             <a:r>
-              <a:t>正式合成样本
-中文 250 + 英文 250</a:t>
+              <a:t>官方 test
+2,542 段英文对话</a:t>
             </a:r>
           </a:p>
         </p:txBody>
@@ -5116,6 +5181,53 @@
         <p:spPr>
           <a:xfrm xmlns:a="http://schemas.openxmlformats.org/drawingml/2006/main">
             <a:off x="8541830" y="4900613"/>
+            <a:ext cx="2949607" cy="819150"/>
+          </a:xfrm>
+          <a:prstGeom xmlns:a="http://schemas.openxmlformats.org/drawingml/2006/main" prst="rect">
+            <a:avLst/>
+          </a:prstGeom>
+        </p:spPr>
+        <p:txBody>
+          <a:bodyPr xmlns:a="http://schemas.openxmlformats.org/drawingml/2006/main" lIns="91440" tIns="45720" rIns="91440" bIns="45720">
+            <a:normAutofit fontScale="99479"/>
+          </a:bodyPr>
+          <a:lstStyle xmlns:a="http://schemas.openxmlformats.org/drawingml/2006/main"/>
+          <a:p xmlns:a="http://schemas.openxmlformats.org/drawingml/2006/main">
+            <a:pPr algn="l">
+              <a:buNone/>
+              <a:defRPr sz="2400">
+                <a:solidFill>
+                  <a:srgbClr val="000000"/>
+                </a:solidFill>
+                <a:latin typeface="Helvetica Neue"/>
+                <a:ea typeface="Helvetica Neue"/>
+                <a:cs typeface="Helvetica Neue"/>
+              </a:defRPr>
+            </a:pPr>
+            <a:r>
+              <a:t>生成式 AI 自建样本
+已从仓库完全移除</a:t>
+            </a:r>
+          </a:p>
+        </p:txBody>
+      </p:sp>
+      <p:sp>
+        <p:nvSpPr>
+          <p:cNvPr id="8" name="Content-Placeholder-11-8">
+            <a:extLst xmlns:a="http://schemas.openxmlformats.org/drawingml/2006/main">
+              <a:ext uri="{FF2B5EF4-FFF2-40B4-BE49-F238E27FC236}">
+                <a16:creationId xmlns:a16="http://schemas.microsoft.com/office/drawing/2014/main" id="{57011A07-1FF4-4BC8-BF91-965EDDC6F90F}"/>
+              </a:ext>
+            </a:extLst>
+          </p:cNvPr>
+          <p:cNvSpPr>
+            <a:spLocks xmlns:a="http://schemas.openxmlformats.org/drawingml/2006/main" noGrp="1"/>
+          </p:cNvSpPr>
+          <p:nvPr/>
+        </p:nvSpPr>
+        <p:spPr>
+          <a:xfrm xmlns:a="http://schemas.openxmlformats.org/drawingml/2006/main">
+            <a:off x="4621244" y="4900613"/>
             <a:ext cx="2949607" cy="819150"/>
           </a:xfrm>
           <a:prstGeom xmlns:a="http://schemas.openxmlformats.org/drawingml/2006/main" prst="rect">
@@ -5129,6 +5241,7 @@
           <a:lstStyle xmlns:a="http://schemas.openxmlformats.org/drawingml/2006/main"/>
           <a:p xmlns:a="http://schemas.openxmlformats.org/drawingml/2006/main">
             <a:pPr algn="l">
+              <a:buNone/>
               <a:defRPr sz="2400">
                 <a:solidFill>
                   <a:srgbClr val="000000"/>
@@ -5139,54 +5252,8 @@
               </a:defRPr>
             </a:pPr>
             <a:r>
-              <a:t>独立人工复标与仲裁
-因此只作工程诊断</a:t>
-            </a:r>
-          </a:p>
-        </p:txBody>
-      </p:sp>
-      <p:sp>
-        <p:nvSpPr>
-          <p:cNvPr id="8" name="Content-Placeholder-11-8">
-            <a:extLst xmlns:a="http://schemas.openxmlformats.org/drawingml/2006/main">
-              <a:ext uri="{FF2B5EF4-FFF2-40B4-BE49-F238E27FC236}">
-                <a16:creationId xmlns:a16="http://schemas.microsoft.com/office/drawing/2014/main" id="{57011A07-1FF4-4BC8-BF91-965EDDC6F90F}"/>
-              </a:ext>
-            </a:extLst>
-          </p:cNvPr>
-          <p:cNvSpPr>
-            <a:spLocks xmlns:a="http://schemas.openxmlformats.org/drawingml/2006/main" noGrp="1"/>
-          </p:cNvSpPr>
-          <p:nvPr/>
-        </p:nvSpPr>
-        <p:spPr>
-          <a:xfrm xmlns:a="http://schemas.openxmlformats.org/drawingml/2006/main">
-            <a:off x="4621244" y="4900613"/>
-            <a:ext cx="2949607" cy="819150"/>
-          </a:xfrm>
-          <a:prstGeom xmlns:a="http://schemas.openxmlformats.org/drawingml/2006/main" prst="rect">
-            <a:avLst/>
-          </a:prstGeom>
-        </p:spPr>
-        <p:txBody>
-          <a:bodyPr xmlns:a="http://schemas.openxmlformats.org/drawingml/2006/main" lIns="91440" tIns="45720" rIns="91440" bIns="45720">
-            <a:normAutofit fontScale="99479"/>
-          </a:bodyPr>
-          <a:lstStyle xmlns:a="http://schemas.openxmlformats.org/drawingml/2006/main"/>
-          <a:p xmlns:a="http://schemas.openxmlformats.org/drawingml/2006/main">
-            <a:pPr algn="l">
-              <a:defRPr sz="2400">
-                <a:solidFill>
-                  <a:srgbClr val="000000"/>
-                </a:solidFill>
-                <a:latin typeface="Helvetica Neue"/>
-                <a:ea typeface="Helvetica Neue"/>
-                <a:cs typeface="Helvetica Neue"/>
-              </a:defRPr>
-            </a:pPr>
-            <a:r>
-              <a:t>目标情绪类别
-两种语言均覆盖</a:t>
+              <a:t>情绪类别
+与项目标签逐项一致</a:t>
             </a:r>
           </a:p>
         </p:txBody>
@@ -5221,6 +5288,7 @@
           <a:lstStyle xmlns:a="http://schemas.openxmlformats.org/drawingml/2006/main"/>
           <a:p xmlns:a="http://schemas.openxmlformats.org/drawingml/2006/main">
             <a:pPr algn="l">
+              <a:buNone/>
               <a:defRPr sz="2400">
                 <a:solidFill>
                   <a:srgbClr val="000000"/>
@@ -5231,7 +5299,7 @@
               </a:defRPr>
             </a:pPr>
             <a:r>
-              <a:t>500</a:t>
+              <a:t>2,542</a:t>
             </a:r>
           </a:p>
         </p:txBody>
@@ -5266,6 +5334,7 @@
           <a:lstStyle xmlns:a="http://schemas.openxmlformats.org/drawingml/2006/main"/>
           <a:p xmlns:a="http://schemas.openxmlformats.org/drawingml/2006/main">
             <a:pPr algn="l">
+              <a:buNone/>
               <a:defRPr sz="2400">
                 <a:solidFill>
                   <a:srgbClr val="000000"/>
@@ -5311,6 +5380,7 @@
           <a:lstStyle xmlns:a="http://schemas.openxmlformats.org/drawingml/2006/main"/>
           <a:p xmlns:a="http://schemas.openxmlformats.org/drawingml/2006/main">
             <a:pPr algn="l">
+              <a:buNone/>
               <a:defRPr sz="2400">
                 <a:solidFill>
                   <a:srgbClr val="000000"/>
@@ -5356,6 +5426,7 @@
           <a:lstStyle xmlns:a="http://schemas.openxmlformats.org/drawingml/2006/main"/>
           <a:p xmlns:a="http://schemas.openxmlformats.org/drawingml/2006/main">
             <a:pPr algn="l">
+              <a:buNone/>
               <a:defRPr sz="1600">
                 <a:solidFill>
                   <a:srgbClr val="000000"/>
@@ -5366,11 +5437,12 @@
               </a:defRPr>
             </a:pPr>
             <a:r>
-              <a:t>Emotion Ablation V2</a:t>
-            </a:r>
-          </a:p>
-          <a:p xmlns:a="http://schemas.openxmlformats.org/drawingml/2006/main">
-            <a:pPr algn="l">
+              <a:t>EmpatheticDialogues 是唯一正式基准</a:t>
+            </a:r>
+          </a:p>
+          <a:p xmlns:a="http://schemas.openxmlformats.org/drawingml/2006/main">
+            <a:pPr algn="l">
+              <a:buNone/>
               <a:defRPr sz="1600">
                 <a:solidFill>
                   <a:srgbClr val="000000"/>
@@ -5381,7 +5453,7 @@
               </a:defRPr>
             </a:pPr>
             <a:r>
-              <a:t>类别均衡、双语、确定性生成，适合验证数据校验、模型调用和指标统计；但 expected 是生成目标，不是独立人工真值。</a:t>
+              <a:t>公开来源、人工众包撰写、许可与 SHA-256 可追溯；实验不再使用自建生成数据，也不保留相关分数。</a:t>
             </a:r>
           </a:p>
         </p:txBody>
@@ -5438,6 +5510,7 @@
           <a:lstStyle xmlns:a="http://schemas.openxmlformats.org/drawingml/2006/main"/>
           <a:p xmlns:a="http://schemas.openxmlformats.org/drawingml/2006/main">
             <a:pPr algn="r">
+              <a:buNone/>
               <a:defRPr sz="1000">
                 <a:solidFill>
                   <a:srgbClr val="000000"/>
@@ -5483,6 +5556,7 @@
           <a:lstStyle xmlns:a="http://schemas.openxmlformats.org/drawingml/2006/main"/>
           <a:p xmlns:a="http://schemas.openxmlformats.org/drawingml/2006/main">
             <a:pPr algn="l">
+              <a:buNone/>
               <a:defRPr sz="2900">
                 <a:solidFill>
                   <a:srgbClr val="000000"/>
@@ -5493,7 +5567,7 @@
               </a:defRPr>
             </a:pPr>
             <a:r>
-              <a:t>原始消融设计包含五组对照</a:t>
+              <a:t>消融框架定义五组对照</a:t>
             </a:r>
           </a:p>
         </p:txBody>
@@ -5528,6 +5602,7 @@
           <a:lstStyle xmlns:a="http://schemas.openxmlformats.org/drawingml/2006/main"/>
           <a:p xmlns:a="http://schemas.openxmlformats.org/drawingml/2006/main">
             <a:pPr algn="l">
+              <a:buNone/>
               <a:defRPr sz="1600">
                 <a:solidFill>
                   <a:srgbClr val="000000"/>
@@ -5543,6 +5618,7 @@
           </a:p>
           <a:p xmlns:a="http://schemas.openxmlformats.org/drawingml/2006/main">
             <a:pPr algn="l">
+              <a:buNone/>
               <a:defRPr sz="1600">
                 <a:solidFill>
                   <a:srgbClr val="000000"/>
@@ -5560,7 +5636,7 @@
       </p:sp>
       <p:graphicFrame>
         <p:nvGraphicFramePr>
-          <p:cNvPr id="10" name="Google-Shape-644-p93-5"/>
+          <p:cNvPr id="13" name="Google-Shape-644-p93-5"/>
           <p:cNvGraphicFramePr/>
           <p:nvPr/>
         </p:nvGraphicFramePr>
@@ -6174,7 +6250,7 @@
       </p:sp>
       <p:graphicFrame>
         <p:nvGraphicFramePr>
-          <p:cNvPr id="12" name=""/>
+          <p:cNvPr id="15" name=""/>
           <p:cNvGraphicFramePr/>
           <p:nvPr/>
         </p:nvGraphicFramePr>
@@ -6791,6 +6867,7 @@
           <a:lstStyle xmlns:a="http://schemas.openxmlformats.org/drawingml/2006/main"/>
           <a:p xmlns:a="http://schemas.openxmlformats.org/drawingml/2006/main">
             <a:pPr algn="r">
+              <a:buNone/>
               <a:defRPr sz="1000">
                 <a:solidFill>
                   <a:srgbClr val="000000"/>
@@ -6836,6 +6913,7 @@
           <a:lstStyle xmlns:a="http://schemas.openxmlformats.org/drawingml/2006/main"/>
           <a:p xmlns:a="http://schemas.openxmlformats.org/drawingml/2006/main">
             <a:pPr algn="l">
+              <a:buNone/>
               <a:defRPr sz="2900">
                 <a:solidFill>
                   <a:srgbClr val="000000"/>
@@ -6846,7 +6924,7 @@
               </a:defRPr>
             </a:pPr>
             <a:r>
-              <a:t>导师质疑推动基准从“可运行”走向“可参考”</a:t>
+              <a:t>公开数据选型优先可追溯性与任务匹配</a:t>
             </a:r>
           </a:p>
         </p:txBody>
@@ -6910,6 +6988,7 @@
           <a:lstStyle xmlns:a="http://schemas.openxmlformats.org/drawingml/2006/main"/>
           <a:p xmlns:a="http://schemas.openxmlformats.org/drawingml/2006/main">
             <a:pPr algn="l">
+              <a:buNone/>
               <a:defRPr sz="2400">
                 <a:solidFill>
                   <a:srgbClr val="000000"/>
@@ -6920,7 +6999,7 @@
               </a:defRPr>
             </a:pPr>
             <a:r>
-              <a:t>合成数据</a:t>
+              <a:t>选型标准</a:t>
             </a:r>
           </a:p>
         </p:txBody>
@@ -6955,6 +7034,7 @@
           <a:lstStyle xmlns:a="http://schemas.openxmlformats.org/drawingml/2006/main"/>
           <a:p xmlns:a="http://schemas.openxmlformats.org/drawingml/2006/main">
             <a:pPr algn="l">
+              <a:buNone/>
               <a:defRPr sz="1600">
                 <a:solidFill>
                   <a:srgbClr val="000000"/>
@@ -6965,11 +7045,12 @@
               </a:defRPr>
             </a:pPr>
             <a:r>
-              <a:t>格式统一、类别均衡</a:t>
-            </a:r>
-          </a:p>
-          <a:p xmlns:a="http://schemas.openxmlformats.org/drawingml/2006/main">
-            <a:pPr algn="l">
+              <a:t>公开来源与许可清晰</a:t>
+            </a:r>
+          </a:p>
+          <a:p xmlns:a="http://schemas.openxmlformats.org/drawingml/2006/main">
+            <a:pPr algn="l">
+              <a:buNone/>
               <a:defRPr sz="1600">
                 <a:solidFill>
                   <a:srgbClr val="000000"/>
@@ -6980,11 +7061,12 @@
               </a:defRPr>
             </a:pPr>
             <a:r>
-              <a:t>可验证运行链路</a:t>
-            </a:r>
-          </a:p>
-          <a:p xmlns:a="http://schemas.openxmlformats.org/drawingml/2006/main">
-            <a:pPr algn="l">
+              <a:t>人工参与者撰写</a:t>
+            </a:r>
+          </a:p>
+          <a:p xmlns:a="http://schemas.openxmlformats.org/drawingml/2006/main">
+            <a:pPr algn="l">
+              <a:buNone/>
               <a:defRPr sz="1600">
                 <a:solidFill>
                   <a:srgbClr val="000000"/>
@@ -6995,7 +7077,7 @@
               </a:defRPr>
             </a:pPr>
             <a:r>
-              <a:t>缺少独立人工真值</a:t>
+              <a:t>标签体系可直接复用</a:t>
             </a:r>
           </a:p>
         </p:txBody>
@@ -7059,6 +7141,7 @@
           <a:lstStyle xmlns:a="http://schemas.openxmlformats.org/drawingml/2006/main"/>
           <a:p xmlns:a="http://schemas.openxmlformats.org/drawingml/2006/main">
             <a:pPr algn="l">
+              <a:buNone/>
               <a:defRPr sz="2400">
                 <a:solidFill>
                   <a:srgbClr val="000000"/>
@@ -7104,6 +7187,7 @@
           <a:lstStyle xmlns:a="http://schemas.openxmlformats.org/drawingml/2006/main"/>
           <a:p xmlns:a="http://schemas.openxmlformats.org/drawingml/2006/main">
             <a:pPr algn="l">
+              <a:buNone/>
               <a:defRPr sz="1600">
                 <a:solidFill>
                   <a:srgbClr val="000000"/>
@@ -7119,6 +7203,7 @@
           </a:p>
           <a:p xmlns:a="http://schemas.openxmlformats.org/drawingml/2006/main">
             <a:pPr algn="l">
+              <a:buNone/>
               <a:defRPr sz="1600">
                 <a:solidFill>
                   <a:srgbClr val="000000"/>
@@ -7134,6 +7219,7 @@
           </a:p>
           <a:p xmlns:a="http://schemas.openxmlformats.org/drawingml/2006/main">
             <a:pPr algn="l">
+              <a:buNone/>
               <a:defRPr sz="1600">
                 <a:solidFill>
                   <a:srgbClr val="000000"/>
@@ -7179,6 +7265,7 @@
           <a:lstStyle xmlns:a="http://schemas.openxmlformats.org/drawingml/2006/main"/>
           <a:p xmlns:a="http://schemas.openxmlformats.org/drawingml/2006/main">
             <a:pPr algn="l">
+              <a:buNone/>
               <a:defRPr sz="1600">
                 <a:solidFill>
                   <a:srgbClr val="000000"/>
@@ -7194,6 +7281,7 @@
           </a:p>
           <a:p xmlns:a="http://schemas.openxmlformats.org/drawingml/2006/main">
             <a:pPr algn="l">
+              <a:buNone/>
               <a:defRPr sz="1600">
                 <a:solidFill>
                   <a:srgbClr val="000000"/>
@@ -7204,11 +7292,12 @@
               </a:defRPr>
             </a:pPr>
             <a:r>
-              <a:t>合成数据保留作诊断；主基准切换为公开、人工撰写且标签体系一致的数据。</a:t>
-            </a:r>
-          </a:p>
-          <a:p xmlns:a="http://schemas.openxmlformats.org/drawingml/2006/main">
-            <a:pPr algn="l">
+              <a:t>EmpatheticDialogues 作为唯一正式基准；其余候选按标签一致性、多轮结构和许可边界进行比较。</a:t>
+            </a:r>
+          </a:p>
+          <a:p xmlns:a="http://schemas.openxmlformats.org/drawingml/2006/main">
+            <a:pPr algn="l">
+              <a:buNone/>
               <a:defRPr sz="1600">
                 <a:solidFill>
                   <a:srgbClr val="000000"/>
@@ -7276,6 +7365,7 @@
           <a:lstStyle xmlns:a="http://schemas.openxmlformats.org/drawingml/2006/main"/>
           <a:p xmlns:a="http://schemas.openxmlformats.org/drawingml/2006/main">
             <a:pPr algn="r">
+              <a:buNone/>
               <a:defRPr sz="1000">
                 <a:solidFill>
                   <a:srgbClr val="000000"/>
@@ -7321,6 +7411,7 @@
           <a:lstStyle xmlns:a="http://schemas.openxmlformats.org/drawingml/2006/main"/>
           <a:p xmlns:a="http://schemas.openxmlformats.org/drawingml/2006/main">
             <a:pPr algn="l">
+              <a:buNone/>
               <a:defRPr sz="2900">
                 <a:solidFill>
                   <a:srgbClr val="000000"/>
@@ -7331,7 +7422,7 @@
               </a:defRPr>
             </a:pPr>
             <a:r>
-              <a:t>第一次真实数据低准确率，主要是评测问题</a:t>
+              <a:t>第一次公开数据低准确率，主要是评测问题</a:t>
             </a:r>
           </a:p>
         </p:txBody>
@@ -7424,6 +7515,7 @@
           <a:lstStyle xmlns:a="http://schemas.openxmlformats.org/drawingml/2006/main"/>
           <a:p xmlns:a="http://schemas.openxmlformats.org/drawingml/2006/main">
             <a:pPr algn="l">
+              <a:buNone/>
               <a:defRPr sz="2400">
                 <a:solidFill>
                   <a:srgbClr val="000000"/>
@@ -7439,6 +7531,7 @@
           </a:p>
           <a:p xmlns:a="http://schemas.openxmlformats.org/drawingml/2006/main">
             <a:pPr algn="l">
+              <a:buNone/>
               <a:defRPr sz="2400">
                 <a:solidFill>
                   <a:srgbClr val="000000"/>
@@ -7485,6 +7578,7 @@
           <a:lstStyle xmlns:a="http://schemas.openxmlformats.org/drawingml/2006/main"/>
           <a:p xmlns:a="http://schemas.openxmlformats.org/drawingml/2006/main">
             <a:pPr algn="l">
+              <a:buNone/>
               <a:defRPr sz="2400">
                 <a:solidFill>
                   <a:srgbClr val="000000"/>
@@ -7500,6 +7594,7 @@
           </a:p>
           <a:p xmlns:a="http://schemas.openxmlformats.org/drawingml/2006/main">
             <a:pPr algn="l">
+              <a:buNone/>
               <a:defRPr sz="2400">
                 <a:solidFill>
                   <a:srgbClr val="000000"/>
@@ -7823,6 +7918,7 @@
           <a:lstStyle xmlns:a="http://schemas.openxmlformats.org/drawingml/2006/main"/>
           <a:p xmlns:a="http://schemas.openxmlformats.org/drawingml/2006/main">
             <a:pPr algn="l">
+              <a:buNone/>
               <a:defRPr sz="2400">
                 <a:solidFill>
                   <a:srgbClr val="000000"/>
@@ -7838,6 +7934,7 @@
           </a:p>
           <a:p xmlns:a="http://schemas.openxmlformats.org/drawingml/2006/main">
             <a:pPr algn="l">
+              <a:buNone/>
               <a:defRPr sz="2400">
                 <a:solidFill>
                   <a:srgbClr val="000000"/>
@@ -8008,6 +8105,7 @@
           <a:lstStyle xmlns:a="http://schemas.openxmlformats.org/drawingml/2006/main"/>
           <a:p xmlns:a="http://schemas.openxmlformats.org/drawingml/2006/main">
             <a:pPr algn="l">
+              <a:buNone/>
               <a:defRPr sz="1600">
                 <a:solidFill>
                   <a:srgbClr val="000000"/>
@@ -8023,6 +8121,7 @@
           </a:p>
           <a:p xmlns:a="http://schemas.openxmlformats.org/drawingml/2006/main">
             <a:pPr algn="l">
+              <a:buNone/>
               <a:defRPr sz="1600">
                 <a:solidFill>
                   <a:srgbClr val="000000"/>
@@ -8038,6 +8137,7 @@
           </a:p>
           <a:p xmlns:a="http://schemas.openxmlformats.org/drawingml/2006/main">
             <a:pPr algn="l">
+              <a:buNone/>
               <a:defRPr sz="1600">
                 <a:solidFill>
                   <a:srgbClr val="000000"/>
@@ -8103,6 +8203,7 @@
           <a:lstStyle xmlns:a="http://schemas.openxmlformats.org/drawingml/2006/main"/>
           <a:p xmlns:a="http://schemas.openxmlformats.org/drawingml/2006/main">
             <a:pPr algn="r">
+              <a:buNone/>
               <a:defRPr sz="1000">
                 <a:solidFill>
                   <a:srgbClr val="000000"/>
@@ -8148,6 +8249,7 @@
           <a:lstStyle xmlns:a="http://schemas.openxmlformats.org/drawingml/2006/main"/>
           <a:p xmlns:a="http://schemas.openxmlformats.org/drawingml/2006/main">
             <a:pPr algn="l">
+              <a:buNone/>
               <a:defRPr sz="2900">
                 <a:solidFill>
                   <a:srgbClr val="000000"/>
@@ -8193,6 +8295,7 @@
           <a:lstStyle xmlns:a="http://schemas.openxmlformats.org/drawingml/2006/main"/>
           <a:p xmlns:a="http://schemas.openxmlformats.org/drawingml/2006/main">
             <a:pPr algn="l">
+              <a:buNone/>
               <a:defRPr sz="1600">
                 <a:solidFill>
                   <a:srgbClr val="000000"/>
@@ -8208,6 +8311,7 @@
           </a:p>
           <a:p xmlns:a="http://schemas.openxmlformats.org/drawingml/2006/main">
             <a:pPr algn="l">
+              <a:buNone/>
               <a:defRPr sz="1600">
                 <a:solidFill>
                   <a:srgbClr val="000000"/>
@@ -8253,6 +8357,7 @@
           <a:lstStyle xmlns:a="http://schemas.openxmlformats.org/drawingml/2006/main"/>
           <a:p xmlns:a="http://schemas.openxmlformats.org/drawingml/2006/main">
             <a:pPr algn="l">
+              <a:buNone/>
               <a:defRPr sz="1800">
                 <a:solidFill>
                   <a:srgbClr val="000000"/>
@@ -8268,6 +8373,7 @@
           </a:p>
           <a:p xmlns:a="http://schemas.openxmlformats.org/drawingml/2006/main">
             <a:pPr algn="l">
+              <a:buNone/>
               <a:defRPr sz="1800">
                 <a:solidFill>
                   <a:srgbClr val="000000"/>
@@ -8313,6 +8419,7 @@
           <a:lstStyle xmlns:a="http://schemas.openxmlformats.org/drawingml/2006/main"/>
           <a:p xmlns:a="http://schemas.openxmlformats.org/drawingml/2006/main">
             <a:pPr algn="l">
+              <a:buNone/>
               <a:defRPr sz="1600">
                 <a:solidFill>
                   <a:srgbClr val="000000"/>
@@ -8328,6 +8435,7 @@
           </a:p>
           <a:p xmlns:a="http://schemas.openxmlformats.org/drawingml/2006/main">
             <a:pPr algn="l">
+              <a:buNone/>
               <a:defRPr sz="1600">
                 <a:solidFill>
                   <a:srgbClr val="000000"/>
@@ -8373,6 +8481,7 @@
           <a:lstStyle xmlns:a="http://schemas.openxmlformats.org/drawingml/2006/main"/>
           <a:p xmlns:a="http://schemas.openxmlformats.org/drawingml/2006/main">
             <a:pPr algn="l">
+              <a:buNone/>
               <a:defRPr sz="1800">
                 <a:solidFill>
                   <a:srgbClr val="000000"/>
@@ -8388,6 +8497,7 @@
           </a:p>
           <a:p xmlns:a="http://schemas.openxmlformats.org/drawingml/2006/main">
             <a:pPr algn="l">
+              <a:buNone/>
               <a:defRPr sz="1800">
                 <a:solidFill>
                   <a:srgbClr val="000000"/>
@@ -8433,6 +8543,7 @@
           <a:lstStyle xmlns:a="http://schemas.openxmlformats.org/drawingml/2006/main"/>
           <a:p xmlns:a="http://schemas.openxmlformats.org/drawingml/2006/main">
             <a:pPr algn="l">
+              <a:buNone/>
               <a:defRPr sz="1600">
                 <a:solidFill>
                   <a:srgbClr val="000000"/>
@@ -8448,6 +8559,7 @@
           </a:p>
           <a:p xmlns:a="http://schemas.openxmlformats.org/drawingml/2006/main">
             <a:pPr algn="l">
+              <a:buNone/>
               <a:defRPr sz="1600">
                 <a:solidFill>
                   <a:srgbClr val="000000"/>
@@ -8493,6 +8605,7 @@
           <a:lstStyle xmlns:a="http://schemas.openxmlformats.org/drawingml/2006/main"/>
           <a:p xmlns:a="http://schemas.openxmlformats.org/drawingml/2006/main">
             <a:pPr algn="l">
+              <a:buNone/>
               <a:defRPr sz="1800">
                 <a:solidFill>
                   <a:srgbClr val="000000"/>
@@ -8508,6 +8621,7 @@
           </a:p>
           <a:p xmlns:a="http://schemas.openxmlformats.org/drawingml/2006/main">
             <a:pPr algn="l">
+              <a:buNone/>
               <a:defRPr sz="1800">
                 <a:solidFill>
                   <a:srgbClr val="000000"/>
@@ -8553,6 +8667,7 @@
           <a:lstStyle xmlns:a="http://schemas.openxmlformats.org/drawingml/2006/main"/>
           <a:p xmlns:a="http://schemas.openxmlformats.org/drawingml/2006/main">
             <a:pPr algn="l">
+              <a:buNone/>
               <a:defRPr sz="1600">
                 <a:solidFill>
                   <a:srgbClr val="000000"/>
@@ -8568,6 +8683,7 @@
           </a:p>
           <a:p xmlns:a="http://schemas.openxmlformats.org/drawingml/2006/main">
             <a:pPr algn="l">
+              <a:buNone/>
               <a:defRPr sz="1600">
                 <a:solidFill>
                   <a:srgbClr val="000000"/>
@@ -8613,6 +8729,7 @@
           <a:lstStyle xmlns:a="http://schemas.openxmlformats.org/drawingml/2006/main"/>
           <a:p xmlns:a="http://schemas.openxmlformats.org/drawingml/2006/main">
             <a:pPr algn="l">
+              <a:buNone/>
               <a:defRPr sz="1800">
                 <a:solidFill>
                   <a:srgbClr val="000000"/>
@@ -8628,6 +8745,7 @@
           </a:p>
           <a:p xmlns:a="http://schemas.openxmlformats.org/drawingml/2006/main">
             <a:pPr algn="l">
+              <a:buNone/>
               <a:defRPr sz="1800">
                 <a:solidFill>
                   <a:srgbClr val="000000"/>
@@ -8780,6 +8898,7 @@
           <a:lstStyle xmlns:a="http://schemas.openxmlformats.org/drawingml/2006/main"/>
           <a:p xmlns:a="http://schemas.openxmlformats.org/drawingml/2006/main">
             <a:pPr algn="r">
+              <a:buNone/>
               <a:defRPr sz="1000">
                 <a:solidFill>
                   <a:srgbClr val="000000"/>
@@ -8825,6 +8944,7 @@
           <a:lstStyle xmlns:a="http://schemas.openxmlformats.org/drawingml/2006/main"/>
           <a:p xmlns:a="http://schemas.openxmlformats.org/drawingml/2006/main">
             <a:pPr algn="l">
+              <a:buNone/>
               <a:defRPr sz="2900">
                 <a:solidFill>
                   <a:srgbClr val="000000"/>
@@ -8870,6 +8990,7 @@
           <a:lstStyle xmlns:a="http://schemas.openxmlformats.org/drawingml/2006/main"/>
           <a:p xmlns:a="http://schemas.openxmlformats.org/drawingml/2006/main">
             <a:pPr algn="l">
+              <a:buNone/>
               <a:defRPr sz="2400">
                 <a:solidFill>
                   <a:srgbClr val="000000"/>
@@ -8916,6 +9037,7 @@
           <a:lstStyle xmlns:a="http://schemas.openxmlformats.org/drawingml/2006/main"/>
           <a:p xmlns:a="http://schemas.openxmlformats.org/drawingml/2006/main">
             <a:pPr algn="l">
+              <a:buNone/>
               <a:defRPr sz="2400">
                 <a:solidFill>
                   <a:srgbClr val="000000"/>
@@ -8962,6 +9084,7 @@
           <a:lstStyle xmlns:a="http://schemas.openxmlformats.org/drawingml/2006/main"/>
           <a:p xmlns:a="http://schemas.openxmlformats.org/drawingml/2006/main">
             <a:pPr algn="l">
+              <a:buNone/>
               <a:defRPr sz="2400">
                 <a:solidFill>
                   <a:srgbClr val="000000"/>
@@ -9008,6 +9131,7 @@
           <a:lstStyle xmlns:a="http://schemas.openxmlformats.org/drawingml/2006/main"/>
           <a:p xmlns:a="http://schemas.openxmlformats.org/drawingml/2006/main">
             <a:pPr algn="l">
+              <a:buNone/>
               <a:defRPr sz="2400">
                 <a:solidFill>
                   <a:srgbClr val="000000"/>
@@ -9053,6 +9177,7 @@
           <a:lstStyle xmlns:a="http://schemas.openxmlformats.org/drawingml/2006/main"/>
           <a:p xmlns:a="http://schemas.openxmlformats.org/drawingml/2006/main">
             <a:pPr algn="l">
+              <a:buNone/>
               <a:defRPr sz="2400">
                 <a:solidFill>
                   <a:srgbClr val="000000"/>
@@ -9098,6 +9223,7 @@
           <a:lstStyle xmlns:a="http://schemas.openxmlformats.org/drawingml/2006/main"/>
           <a:p xmlns:a="http://schemas.openxmlformats.org/drawingml/2006/main">
             <a:pPr algn="l">
+              <a:buNone/>
               <a:defRPr sz="2400">
                 <a:solidFill>
                   <a:srgbClr val="000000"/>
@@ -9143,6 +9269,7 @@
           <a:lstStyle xmlns:a="http://schemas.openxmlformats.org/drawingml/2006/main"/>
           <a:p xmlns:a="http://schemas.openxmlformats.org/drawingml/2006/main">
             <a:pPr algn="l">
+              <a:buNone/>
               <a:defRPr sz="1600">
                 <a:solidFill>
                   <a:srgbClr val="000000"/>
@@ -9158,6 +9285,7 @@
           </a:p>
           <a:p xmlns:a="http://schemas.openxmlformats.org/drawingml/2006/main">
             <a:pPr algn="l">
+              <a:buNone/>
               <a:defRPr sz="1600">
                 <a:solidFill>
                   <a:srgbClr val="000000"/>

</xml_diff>

<commit_message>
chore: remove Codex-specific artifacts
</commit_message>
<xml_diff>
--- a/deliverables/advisor_full_summary_20260728/emotion_chatbot_ablation_report.pptx
+++ b/deliverables/advisor_full_summary_20260728/emotion_chatbot_ablation_report.pptx
@@ -2,24 +2,24 @@
 <file path=ppt/presentation.xml><?xml version="1.0" encoding="utf-8"?>
 <p:presentation xmlns:p="http://schemas.openxmlformats.org/presentationml/2006/main">
   <p:sldMasterIdLst>
-    <p:sldMasterId xmlns:r="http://schemas.openxmlformats.org/officeDocument/2006/relationships" id="2147483648" r:id="Rfa92c53b202b445b"/>
+    <p:sldMasterId xmlns:r="http://schemas.openxmlformats.org/officeDocument/2006/relationships" id="2147483648" r:id="Re5b63550117b425e"/>
   </p:sldMasterIdLst>
   <p:notesMasterIdLst>
-    <p:notesMasterId xmlns:r="http://schemas.openxmlformats.org/officeDocument/2006/relationships" r:id="R0cc7eca70f3b4611"/>
+    <p:notesMasterId xmlns:r="http://schemas.openxmlformats.org/officeDocument/2006/relationships" r:id="Rc95d875ebd1f4ddd"/>
   </p:notesMasterIdLst>
   <p:sldIdLst>
-    <p:sldId xmlns:r="http://schemas.openxmlformats.org/officeDocument/2006/relationships" id="256" r:id="R62554e80a59b4c04"/>
-    <p:sldId xmlns:r="http://schemas.openxmlformats.org/officeDocument/2006/relationships" id="257" r:id="R03ccb7ce06b14007"/>
-    <p:sldId xmlns:r="http://schemas.openxmlformats.org/officeDocument/2006/relationships" id="258" r:id="Rb7341417d74a4861"/>
-    <p:sldId xmlns:r="http://schemas.openxmlformats.org/officeDocument/2006/relationships" id="259" r:id="Re6572d7ffbcd41b4"/>
-    <p:sldId xmlns:r="http://schemas.openxmlformats.org/officeDocument/2006/relationships" id="260" r:id="R0acb9019df4f4cfb"/>
-    <p:sldId xmlns:r="http://schemas.openxmlformats.org/officeDocument/2006/relationships" id="261" r:id="R0021259a13554c2e"/>
-    <p:sldId xmlns:r="http://schemas.openxmlformats.org/officeDocument/2006/relationships" id="262" r:id="R841733abb04c40d7"/>
-    <p:sldId xmlns:r="http://schemas.openxmlformats.org/officeDocument/2006/relationships" id="263" r:id="R67f3118092a34d31"/>
-    <p:sldId xmlns:r="http://schemas.openxmlformats.org/officeDocument/2006/relationships" id="264" r:id="Rc225515dc204481c"/>
-    <p:sldId xmlns:r="http://schemas.openxmlformats.org/officeDocument/2006/relationships" id="265" r:id="Rc3dffe3fb8bf4575"/>
-    <p:sldId xmlns:r="http://schemas.openxmlformats.org/officeDocument/2006/relationships" id="266" r:id="Ra2fc868c897641fc"/>
-    <p:sldId xmlns:r="http://schemas.openxmlformats.org/officeDocument/2006/relationships" id="267" r:id="R3486d1f1ad714840"/>
+    <p:sldId xmlns:r="http://schemas.openxmlformats.org/officeDocument/2006/relationships" id="256" r:id="Rfe7bd7ed5a0648cd"/>
+    <p:sldId xmlns:r="http://schemas.openxmlformats.org/officeDocument/2006/relationships" id="257" r:id="R3d78d0ffe0084c37"/>
+    <p:sldId xmlns:r="http://schemas.openxmlformats.org/officeDocument/2006/relationships" id="258" r:id="R901ac108c4a14f1c"/>
+    <p:sldId xmlns:r="http://schemas.openxmlformats.org/officeDocument/2006/relationships" id="259" r:id="R01880f7c929f4bd9"/>
+    <p:sldId xmlns:r="http://schemas.openxmlformats.org/officeDocument/2006/relationships" id="260" r:id="R13a67acdb90948db"/>
+    <p:sldId xmlns:r="http://schemas.openxmlformats.org/officeDocument/2006/relationships" id="261" r:id="Ra67c86a8f57e40b0"/>
+    <p:sldId xmlns:r="http://schemas.openxmlformats.org/officeDocument/2006/relationships" id="262" r:id="Re2d300c23bb94f35"/>
+    <p:sldId xmlns:r="http://schemas.openxmlformats.org/officeDocument/2006/relationships" id="263" r:id="R2fe4fc6d23c14915"/>
+    <p:sldId xmlns:r="http://schemas.openxmlformats.org/officeDocument/2006/relationships" id="264" r:id="R80dcee9ce3054d28"/>
+    <p:sldId xmlns:r="http://schemas.openxmlformats.org/officeDocument/2006/relationships" id="265" r:id="R5ae9be32163e4b1d"/>
+    <p:sldId xmlns:r="http://schemas.openxmlformats.org/officeDocument/2006/relationships" id="266" r:id="R973a157e41404b08"/>
+    <p:sldId xmlns:r="http://schemas.openxmlformats.org/officeDocument/2006/relationships" id="267" r:id="R60e64215c1f4453b"/>
   </p:sldIdLst>
   <p:sldSz cx="12192000" cy="6858000"/>
   <p:notesSz cx="6858000" cy="9144000"/>
@@ -1273,7 +1273,7 @@
           </a:p>
           <a:p xmlns:a="http://schemas.openxmlformats.org/drawingml/2006/main">
             <a:r>
-              <a:t>- data/benchmarks/empathetic_dialogues_v1/reports/codex_pilot10/report-zh.md</a:t>
+              <a:t>- data/benchmarks/empathetic_dialogues_v1/release/context_diagnostic.jsonl</a:t>
             </a:r>
           </a:p>
         </p:txBody>
@@ -1516,7 +1516,7 @@
   </p:cSld>
   <p:clrMap bg1="lt1" tx1="dk1" bg2="lt2" tx2="dk2" accent1="accent1" accent2="accent2" accent3="accent3" accent4="accent4" accent5="accent5" accent6="accent6" hlink="hlink" folHlink="folHlink"/>
   <p:sldLayoutIdLst>
-    <p:sldLayoutId xmlns:r="http://schemas.openxmlformats.org/officeDocument/2006/relationships" id="2147483649" r:id="Rdc3e04d51a3340aa"/>
+    <p:sldLayoutId xmlns:r="http://schemas.openxmlformats.org/officeDocument/2006/relationships" id="2147483649" r:id="R97c1ae7da1af47e0"/>
   </p:sldLayoutIdLst>
   <p:txStyles>
     <p:titleStyle>
@@ -2784,7 +2784,7 @@
         </p:xfrm>
         <a:graphic xmlns:a="http://schemas.openxmlformats.org/drawingml/2006/main">
           <a:graphicData uri="http://schemas.openxmlformats.org/drawingml/2006/chart">
-            <c:chart xmlns:r="http://schemas.openxmlformats.org/officeDocument/2006/relationships" xmlns:c="http://schemas.openxmlformats.org/drawingml/2006/chart" r:id="Reb87700f00ae49a7"/>
+            <c:chart xmlns:r="http://schemas.openxmlformats.org/officeDocument/2006/relationships" xmlns:c="http://schemas.openxmlformats.org/drawingml/2006/chart" r:id="R92fea86da14344cd"/>
           </a:graphicData>
         </a:graphic>
       </p:graphicFrame>
@@ -2933,7 +2933,7 @@
       </p:sp>
       <p:cxnSp>
         <p:nvCxnSpPr>
-          <p:cNvPr id="30" name="Google-Shape-2259-p159-4"/>
+          <p:cNvPr id="36" name="Google-Shape-2259-p159-4"/>
           <p:cNvCxnSpPr/>
           <p:nvPr/>
         </p:nvCxnSpPr>
@@ -3674,7 +3674,7 @@
       </p:sp>
       <p:cxnSp>
         <p:nvCxnSpPr>
-          <p:cNvPr id="30" name="Google-Shape-2259-p159-4"/>
+          <p:cNvPr id="36" name="Google-Shape-2259-p159-4"/>
           <p:cNvCxnSpPr/>
           <p:nvPr/>
         </p:nvCxnSpPr>

</xml_diff>